<commit_message>
docs: 2026-10 deck -- PRs since August, two training stability fixes, V2.5 on EFA
update_slides.py builds DeepEPv2_on_EFA.pptx from the August deck (kept as
DeepEPv2_on_EFA_2026-08.pptx) and computes the V2.5 table from the
deepep-v25-efa-port raw logs.

Co-Authored-By: Claude Opus 5.5 <noreply@anthropic.com>
</commit_message>
<xml_diff>
--- a/deepep-v2-efa-official/docs/DeepEPv2_on_EFA.pptx
+++ b/deepep-v2-efa-official/docs/DeepEPv2_on_EFA.pptx
@@ -17,6 +17,9 @@
     <p:sldId id="265" r:id="rId16"/>
     <p:sldId id="266" r:id="rId17"/>
     <p:sldId id="267" r:id="rId18"/>
+    <p:sldId id="269" r:id="rId20"/>
+    <p:sldId id="270" r:id="rId21"/>
+    <p:sldId id="271" r:id="rId22"/>
     <p:sldId id="268" r:id="rId19"/>
   </p:sldIdLst>
   <p:sldSz cx="12191695" cy="6858000" type="screen4x3"/>
@@ -3129,7 +3132,7 @@
                   <a:srgbClr val="909090"/>
                 </a:solidFill>
               </a:rPr>
-              <a:t>DeepEP V2 on AWS EFA · 2026-08 · 1/13</a:t>
+              <a:t>DeepEP V2 on AWS EFA · 2026-10 · 1/16</a:t>
             </a:r>
           </a:p>
         </p:txBody>
@@ -3176,7 +3179,7 @@
               </a:defRPr>
             </a:pPr>
             <a:r>
-              <a:t>原理 · 安装 · 性能</a:t>
+              <a:t>原理 · 安装 · 性能 · 最新 PR · V2.5</a:t>
             </a:r>
           </a:p>
         </p:txBody>
@@ -3326,7 +3329,7 @@
                   <a:srgbClr val="909090"/>
                 </a:solidFill>
               </a:rPr>
-              <a:t>2026-08 · p5en.48xlarge × 2 / 4</a:t>
+              <a:t>2026-08 初版 · 2026-10 更新 · p5en / p6-b200 / p6-b300</a:t>
             </a:r>
           </a:p>
         </p:txBody>
@@ -3378,7 +3381,7 @@
                   <a:srgbClr val="909090"/>
                 </a:solidFill>
               </a:rPr>
-              <a:t>DeepEP V2 on AWS EFA · 2026-08 · 10/13</a:t>
+              <a:t>DeepEP V2 on AWS EFA · 2026-10 · 10/16</a:t>
             </a:r>
           </a:p>
         </p:txBody>
@@ -4038,7 +4041,7 @@
                   <a:srgbClr val="909090"/>
                 </a:solidFill>
               </a:rPr>
-              <a:t>DeepEP V2 on AWS EFA · 2026-08 · 11/13</a:t>
+              <a:t>DeepEP V2 on AWS EFA · 2026-10 · 11/16</a:t>
             </a:r>
           </a:p>
         </p:txBody>
@@ -4555,7 +4558,7 @@
                             <a:srgbClr val="202020"/>
                           </a:solidFill>
                         </a:rPr>
-                        <a:t>+PR #1 #2</a:t>
+                        <a:t>+PR #1 #2（#2 已经由 #15 进 main）</a:t>
                       </a:r>
                     </a:p>
                   </a:txBody>
@@ -4662,7 +4665,7 @@
                             <a:srgbClr val="202020"/>
                           </a:solidFill>
                         </a:rPr>
-                        <a:t>+ EP_NUM_SUB_PARTS=1</a:t>
+                        <a:t>+ EP_NUM_SUB_PARTS=1（需要 #1，未合）</a:t>
                       </a:r>
                     </a:p>
                   </a:txBody>
@@ -4885,7 +4888,7 @@
                   <a:srgbClr val="909090"/>
                 </a:solidFill>
               </a:rPr>
-              <a:t>DeepEP V2 on AWS EFA · 2026-08 · 12/13</a:t>
+              <a:t>DeepEP V2 on AWS EFA · 2026-10 · 12/16</a:t>
             </a:r>
           </a:p>
         </p:txBody>
@@ -6113,7 +6116,7 @@
                   <a:srgbClr val="909090"/>
                 </a:solidFill>
               </a:rPr>
-              <a:t>DeepEP V2 on AWS EFA · 2026-08 · 13/13</a:t>
+              <a:t>DeepEP V2 on AWS EFA · 2026-10 · 16/16</a:t>
             </a:r>
           </a:p>
         </p:txBody>
@@ -6148,7 +6151,7 @@
               </a:defRPr>
             </a:pPr>
             <a:r>
-              <a:t>12 · 三个坑 + 参考</a:t>
+              <a:t>15 · 三个坑 + 参考</a:t>
             </a:r>
           </a:p>
         </p:txBody>
@@ -6424,7 +6427,7 @@
                   <a:srgbClr val="202020"/>
                 </a:solidFill>
               </a:rPr>
-              <a:t>• 待合 PR：amazon-contributing/DeepEP#1 / #2</a:t>
+              <a:t>• PR：amazon-contributing/DeepEP（第 12–13 页）；V2.5 迁移 #36；V2.5 移植 + 数据：whn09/DeepEP@amazon-v2.5、deepep-v25-efa-port/</a:t>
             </a:r>
           </a:p>
           <a:p>
@@ -6440,6 +6443,2655 @@
                 </a:solidFill>
               </a:rPr>
               <a:t>• 上游 install 参考：awslabs/awsome-distributed-ai deepep-v2-benchmark</a:t>
+            </a:r>
+          </a:p>
+        </p:txBody>
+      </p:sp>
+    </p:spTree>
+  </p:cSld>
+  <p:clrMapOvr>
+    <a:masterClrMapping/>
+  </p:clrMapOvr>
+</p:sld>
+</file>
+
+<file path=ppt/slides/slide14.xml><?xml version="1.0" encoding="utf-8"?>
+<p:sld xmlns:a="http://schemas.openxmlformats.org/drawingml/2006/main" xmlns:p="http://schemas.openxmlformats.org/presentationml/2006/main" xmlns:r="http://schemas.openxmlformats.org/officeDocument/2006/relationships">
+  <p:cSld>
+    <p:spTree>
+      <p:nvGrpSpPr>
+        <p:cNvPr id="1" name=""/>
+        <p:cNvGrpSpPr/>
+        <p:nvPr/>
+      </p:nvGrpSpPr>
+      <p:grpSpPr/>
+      <p:sp>
+        <p:nvSpPr>
+          <p:cNvPr id="2" name="TextBox 1"/>
+          <p:cNvSpPr txBox="1"/>
+          <p:nvPr/>
+        </p:nvSpPr>
+        <p:spPr>
+          <a:xfrm>
+            <a:off x="365760" y="6492240"/>
+            <a:ext cx="11430000" cy="274320"/>
+          </a:xfrm>
+          <a:prstGeom prst="rect">
+            <a:avLst/>
+          </a:prstGeom>
+          <a:noFill/>
+        </p:spPr>
+        <p:txBody>
+          <a:bodyPr wrap="square">
+            <a:spAutoFit/>
+          </a:bodyPr>
+          <a:lstStyle/>
+          <a:p>
+            <a:r>
+              <a:rPr sz="1000" b="0">
+                <a:solidFill>
+                  <a:srgbClr val="909090"/>
+                </a:solidFill>
+              </a:rPr>
+              <a:t>DeepEP V2 on AWS EFA · 2026-10 · 13/16</a:t>
+            </a:r>
+          </a:p>
+        </p:txBody>
+      </p:sp>
+      <p:sp>
+        <p:nvSpPr>
+          <p:cNvPr id="3" name="TextBox 2"/>
+          <p:cNvSpPr txBox="1"/>
+          <p:nvPr/>
+        </p:nvSpPr>
+        <p:spPr>
+          <a:xfrm>
+            <a:off x="457200" y="320040"/>
+            <a:ext cx="11247120" cy="777240"/>
+          </a:xfrm>
+          <a:prstGeom prst="rect">
+            <a:avLst/>
+          </a:prstGeom>
+          <a:noFill/>
+        </p:spPr>
+        <p:txBody>
+          <a:bodyPr wrap="square">
+            <a:spAutoFit/>
+          </a:bodyPr>
+          <a:lstStyle/>
+          <a:p>
+            <a:r>
+              <a:rPr sz="3000" b="1">
+                <a:solidFill>
+                  <a:srgbClr val="1F4E79"/>
+                </a:solidFill>
+              </a:rPr>
+              <a:t>12 · amazon-contributing/DeepEP：8 月以来的 PR</a:t>
+            </a:r>
+          </a:p>
+        </p:txBody>
+      </p:sp>
+      <p:sp>
+        <p:nvSpPr>
+          <p:cNvPr id="4" name="TextBox 3"/>
+          <p:cNvSpPr txBox="1"/>
+          <p:nvPr/>
+        </p:nvSpPr>
+        <p:spPr>
+          <a:xfrm>
+            <a:off x="457200" y="1097280"/>
+            <a:ext cx="11247120" cy="411480"/>
+          </a:xfrm>
+          <a:prstGeom prst="rect">
+            <a:avLst/>
+          </a:prstGeom>
+          <a:noFill/>
+        </p:spPr>
+        <p:txBody>
+          <a:bodyPr wrap="square">
+            <a:spAutoFit/>
+          </a:bodyPr>
+          <a:lstStyle/>
+          <a:p>
+            <a:r>
+              <a:rPr sz="1500" b="1">
+                <a:solidFill>
+                  <a:srgbClr val="C0504D"/>
+                </a:solidFill>
+              </a:rPr>
+              <a:t>main 现在是 51815ea（10-26）；8 月这份 deck 之后合入 10 个 PR，6 个是正确性修复</a:t>
+            </a:r>
+          </a:p>
+        </p:txBody>
+      </p:sp>
+      <p:graphicFrame>
+        <p:nvGraphicFramePr>
+          <p:cNvPr id="5" name="Table 4"/>
+          <p:cNvGraphicFramePr>
+            <a:graphicFrameLocks noGrp="1"/>
+          </p:cNvGraphicFramePr>
+          <p:nvPr/>
+        </p:nvGraphicFramePr>
+        <p:xfrm>
+          <a:off x="457200" y="1600200"/>
+          <a:ext cx="11247120" cy="3657600"/>
+        </p:xfrm>
+        <a:graphic>
+          <a:graphicData uri="http://schemas.openxmlformats.org/drawingml/2006/table">
+            <a:tbl>
+              <a:tblPr firstRow="1" bandRow="1">
+                <a:tableStyleId>{5C22544A-7EE6-4342-B048-85BDC9FD1C3A}</a:tableStyleId>
+              </a:tblPr>
+              <a:tblGrid>
+                <a:gridCol w="685800"/>
+                <a:gridCol w="685800"/>
+                <a:gridCol w="5852160"/>
+                <a:gridCol w="4023360"/>
+              </a:tblGrid>
+              <a:tr h="365760">
+                <a:tc>
+                  <a:txBody>
+                    <a:bodyPr wrap="square"/>
+                    <a:lstStyle/>
+                    <a:p>
+                      <a:r>
+                        <a:rPr sz="1250" b="1">
+                          <a:solidFill>
+                            <a:srgbClr val="FFFFFF"/>
+                          </a:solidFill>
+                        </a:rPr>
+                        <a:t>PR</a:t>
+                      </a:r>
+                    </a:p>
+                  </a:txBody>
+                  <a:tcPr marT="27432" marB="27432">
+                    <a:solidFill>
+                      <a:srgbClr val="2E75B6"/>
+                    </a:solidFill>
+                  </a:tcPr>
+                </a:tc>
+                <a:tc>
+                  <a:txBody>
+                    <a:bodyPr wrap="square"/>
+                    <a:lstStyle/>
+                    <a:p>
+                      <a:r>
+                        <a:rPr sz="1250" b="1">
+                          <a:solidFill>
+                            <a:srgbClr val="FFFFFF"/>
+                          </a:solidFill>
+                        </a:rPr>
+                        <a:t>类型</a:t>
+                      </a:r>
+                    </a:p>
+                  </a:txBody>
+                  <a:tcPr marT="27432" marB="27432">
+                    <a:solidFill>
+                      <a:srgbClr val="2E75B6"/>
+                    </a:solidFill>
+                  </a:tcPr>
+                </a:tc>
+                <a:tc>
+                  <a:txBody>
+                    <a:bodyPr wrap="square"/>
+                    <a:lstStyle/>
+                    <a:p>
+                      <a:r>
+                        <a:rPr sz="1250" b="1">
+                          <a:solidFill>
+                            <a:srgbClr val="FFFFFF"/>
+                          </a:solidFill>
+                        </a:rPr>
+                        <a:t>内容</a:t>
+                      </a:r>
+                    </a:p>
+                  </a:txBody>
+                  <a:tcPr marT="27432" marB="27432">
+                    <a:solidFill>
+                      <a:srgbClr val="2E75B6"/>
+                    </a:solidFill>
+                  </a:tcPr>
+                </a:tc>
+                <a:tc>
+                  <a:txBody>
+                    <a:bodyPr wrap="square"/>
+                    <a:lstStyle/>
+                    <a:p>
+                      <a:r>
+                        <a:rPr sz="1250" b="1">
+                          <a:solidFill>
+                            <a:srgbClr val="FFFFFF"/>
+                          </a:solidFill>
+                        </a:rPr>
+                        <a:t>合入 · 我们的实测</a:t>
+                      </a:r>
+                    </a:p>
+                  </a:txBody>
+                  <a:tcPr marT="27432" marB="27432">
+                    <a:solidFill>
+                      <a:srgbClr val="2E75B6"/>
+                    </a:solidFill>
+                  </a:tcPr>
+                </a:tc>
+              </a:tr>
+              <a:tr h="365760">
+                <a:tc>
+                  <a:txBody>
+                    <a:bodyPr wrap="square"/>
+                    <a:lstStyle/>
+                    <a:p>
+                      <a:r>
+                        <a:rPr sz="1150" b="0">
+                          <a:solidFill>
+                            <a:srgbClr val="202020"/>
+                          </a:solidFill>
+                        </a:rPr>
+                        <a:t>#15</a:t>
+                      </a:r>
+                    </a:p>
+                  </a:txBody>
+                  <a:tcPr marT="27432" marB="27432">
+                    <a:solidFill>
+                      <a:srgbClr val="FFFFFF"/>
+                    </a:solidFill>
+                  </a:tcPr>
+                </a:tc>
+                <a:tc>
+                  <a:txBody>
+                    <a:bodyPr wrap="square"/>
+                    <a:lstStyle/>
+                    <a:p>
+                      <a:r>
+                        <a:rPr sz="1150" b="0">
+                          <a:solidFill>
+                            <a:srgbClr val="202020"/>
+                          </a:solidFill>
+                        </a:rPr>
+                        <a:t>perf</a:t>
+                      </a:r>
+                    </a:p>
+                  </a:txBody>
+                  <a:tcPr marT="27432" marB="27432">
+                    <a:solidFill>
+                      <a:srgbClr val="FFFFFF"/>
+                    </a:solidFill>
+                  </a:tcPr>
+                </a:tc>
+                <a:tc>
+                  <a:txBody>
+                    <a:bodyPr wrap="square"/>
+                    <a:lstStyle/>
+                    <a:p>
+                      <a:r>
+                        <a:rPr sz="1150" b="0">
+                          <a:solidFill>
+                            <a:srgbClr val="202020"/>
+                          </a:solidFill>
+                        </a:rPr>
+                        <a:t>token 少时少切 dispatch part（#2 的 clamp；#1 的 JIT env 透传没合）</a:t>
+                      </a:r>
+                    </a:p>
+                  </a:txBody>
+                  <a:tcPr marT="27432" marB="27432">
+                    <a:solidFill>
+                      <a:srgbClr val="FFFFFF"/>
+                    </a:solidFill>
+                  </a:tcPr>
+                </a:tc>
+                <a:tc>
+                  <a:txBody>
+                    <a:bodyPr wrap="square"/>
+                    <a:lstStyle/>
+                    <a:p>
+                      <a:r>
+                        <a:rPr sz="1150" b="0">
+                          <a:solidFill>
+                            <a:srgbClr val="202020"/>
+                          </a:solidFill>
+                        </a:rPr>
+                        <a:t>09-30 · b300 decode dispatch 277.5 → 129.4 µs</a:t>
+                      </a:r>
+                    </a:p>
+                  </a:txBody>
+                  <a:tcPr marT="27432" marB="27432">
+                    <a:solidFill>
+                      <a:srgbClr val="FFFFFF"/>
+                    </a:solidFill>
+                  </a:tcPr>
+                </a:tc>
+              </a:tr>
+              <a:tr h="365760">
+                <a:tc>
+                  <a:txBody>
+                    <a:bodyPr wrap="square"/>
+                    <a:lstStyle/>
+                    <a:p>
+                      <a:r>
+                        <a:rPr sz="1150" b="0">
+                          <a:solidFill>
+                            <a:srgbClr val="202020"/>
+                          </a:solidFill>
+                        </a:rPr>
+                        <a:t>#17</a:t>
+                      </a:r>
+                    </a:p>
+                  </a:txBody>
+                  <a:tcPr marT="27432" marB="27432">
+                    <a:solidFill>
+                      <a:srgbClr val="FFFFFF"/>
+                    </a:solidFill>
+                  </a:tcPr>
+                </a:tc>
+                <a:tc>
+                  <a:txBody>
+                    <a:bodyPr wrap="square"/>
+                    <a:lstStyle/>
+                    <a:p>
+                      <a:r>
+                        <a:rPr sz="1150" b="0">
+                          <a:solidFill>
+                            <a:srgbClr val="202020"/>
+                          </a:solidFill>
+                        </a:rPr>
+                        <a:t>perf</a:t>
+                      </a:r>
+                    </a:p>
+                  </a:txBody>
+                  <a:tcPr marT="27432" marB="27432">
+                    <a:solidFill>
+                      <a:srgbClr val="FFFFFF"/>
+                    </a:solidFill>
+                  </a:tcPr>
+                </a:tc>
+                <a:tc>
+                  <a:txBody>
+                    <a:bodyPr wrap="square"/>
+                    <a:lstStyle/>
+                    <a:p>
+                      <a:r>
+                        <a:rPr sz="1150" b="0">
+                          <a:solidFill>
+                            <a:srgbClr val="202020"/>
+                          </a:solidFill>
+                        </a:rPr>
+                        <a:t>combine forward chunk 48 → 16 槽</a:t>
+                      </a:r>
+                    </a:p>
+                  </a:txBody>
+                  <a:tcPr marT="27432" marB="27432">
+                    <a:solidFill>
+                      <a:srgbClr val="FFFFFF"/>
+                    </a:solidFill>
+                  </a:tcPr>
+                </a:tc>
+                <a:tc>
+                  <a:txBody>
+                    <a:bodyPr wrap="square"/>
+                    <a:lstStyle/>
+                    <a:p>
+                      <a:r>
+                        <a:rPr sz="1150" b="0">
+                          <a:solidFill>
+                            <a:srgbClr val="202020"/>
+                          </a:solidFill>
+                        </a:rPr>
+                        <a:t>10-19 · b300 prefill dispatch −2.8%，combine 持平</a:t>
+                      </a:r>
+                    </a:p>
+                  </a:txBody>
+                  <a:tcPr marT="27432" marB="27432">
+                    <a:solidFill>
+                      <a:srgbClr val="FFFFFF"/>
+                    </a:solidFill>
+                  </a:tcPr>
+                </a:tc>
+              </a:tr>
+              <a:tr h="365760">
+                <a:tc>
+                  <a:txBody>
+                    <a:bodyPr wrap="square"/>
+                    <a:lstStyle/>
+                    <a:p>
+                      <a:r>
+                        <a:rPr sz="1150" b="0">
+                          <a:solidFill>
+                            <a:srgbClr val="202020"/>
+                          </a:solidFill>
+                        </a:rPr>
+                        <a:t>#14</a:t>
+                      </a:r>
+                    </a:p>
+                  </a:txBody>
+                  <a:tcPr marT="27432" marB="27432">
+                    <a:solidFill>
+                      <a:srgbClr val="FFFFFF"/>
+                    </a:solidFill>
+                  </a:tcPr>
+                </a:tc>
+                <a:tc>
+                  <a:txBody>
+                    <a:bodyPr wrap="square"/>
+                    <a:lstStyle/>
+                    <a:p>
+                      <a:r>
+                        <a:rPr sz="1150" b="0">
+                          <a:solidFill>
+                            <a:srgbClr val="202020"/>
+                          </a:solidFill>
+                        </a:rPr>
+                        <a:t>fix</a:t>
+                      </a:r>
+                    </a:p>
+                  </a:txBody>
+                  <a:tcPr marT="27432" marB="27432">
+                    <a:solidFill>
+                      <a:srgbClr val="FFFFFF"/>
+                    </a:solidFill>
+                  </a:tcPr>
+                </a:tc>
+                <a:tc>
+                  <a:txBody>
+                    <a:bodyPr wrap="square"/>
+                    <a:lstStyle/>
+                    <a:p>
+                      <a:r>
+                        <a:rPr sz="1150" b="0">
+                          <a:solidFill>
+                            <a:srgbClr val="202020"/>
+                          </a:solidFill>
+                        </a:rPr>
+                        <a:t>8 ch/SM 形状下 combine warp 对的寄存器预算</a:t>
+                      </a:r>
+                    </a:p>
+                  </a:txBody>
+                  <a:tcPr marT="27432" marB="27432">
+                    <a:solidFill>
+                      <a:srgbClr val="FFFFFF"/>
+                    </a:solidFill>
+                  </a:tcPr>
+                </a:tc>
+                <a:tc>
+                  <a:txBody>
+                    <a:bodyPr wrap="square"/>
+                    <a:lstStyle/>
+                    <a:p>
+                      <a:r>
+                        <a:rPr sz="1150" b="0">
+                          <a:solidFill>
+                            <a:srgbClr val="202020"/>
+                          </a:solidFill>
+                        </a:rPr>
+                        <a:t>09-09</a:t>
+                      </a:r>
+                    </a:p>
+                  </a:txBody>
+                  <a:tcPr marT="27432" marB="27432">
+                    <a:solidFill>
+                      <a:srgbClr val="FFFFFF"/>
+                    </a:solidFill>
+                  </a:tcPr>
+                </a:tc>
+              </a:tr>
+              <a:tr h="365760">
+                <a:tc>
+                  <a:txBody>
+                    <a:bodyPr wrap="square"/>
+                    <a:lstStyle/>
+                    <a:p>
+                      <a:r>
+                        <a:rPr sz="1150" b="0">
+                          <a:solidFill>
+                            <a:srgbClr val="202020"/>
+                          </a:solidFill>
+                        </a:rPr>
+                        <a:t>#18</a:t>
+                      </a:r>
+                    </a:p>
+                  </a:txBody>
+                  <a:tcPr marT="27432" marB="27432">
+                    <a:solidFill>
+                      <a:srgbClr val="FFFFFF"/>
+                    </a:solidFill>
+                  </a:tcPr>
+                </a:tc>
+                <a:tc>
+                  <a:txBody>
+                    <a:bodyPr wrap="square"/>
+                    <a:lstStyle/>
+                    <a:p>
+                      <a:r>
+                        <a:rPr sz="1150" b="0">
+                          <a:solidFill>
+                            <a:srgbClr val="202020"/>
+                          </a:solidFill>
+                        </a:rPr>
+                        <a:t>fix</a:t>
+                      </a:r>
+                    </a:p>
+                  </a:txBody>
+                  <a:tcPr marT="27432" marB="27432">
+                    <a:solidFill>
+                      <a:srgbClr val="FFFFFF"/>
+                    </a:solidFill>
+                  </a:tcPr>
+                </a:tc>
+                <a:tc>
+                  <a:txBody>
+                    <a:bodyPr wrap="square"/>
+                    <a:lstStyle/>
+                    <a:p>
+                      <a:r>
+                        <a:rPr sz="1150" b="0">
+                          <a:solidFill>
+                            <a:srgbClr val="202020"/>
+                          </a:solidFill>
+                        </a:rPr>
+                        <a:t>cached dispatch 的数据通道避开 QP 0（Xid 13/31）</a:t>
+                      </a:r>
+                    </a:p>
+                  </a:txBody>
+                  <a:tcPr marT="27432" marB="27432">
+                    <a:solidFill>
+                      <a:srgbClr val="FFFFFF"/>
+                    </a:solidFill>
+                  </a:tcPr>
+                </a:tc>
+                <a:tc>
+                  <a:txBody>
+                    <a:bodyPr wrap="square"/>
+                    <a:lstStyle/>
+                    <a:p>
+                      <a:r>
+                        <a:rPr sz="1150" b="0">
+                          <a:solidFill>
+                            <a:srgbClr val="202020"/>
+                          </a:solidFill>
+                        </a:rPr>
+                        <a:t>10-09 · 见下页</a:t>
+                      </a:r>
+                    </a:p>
+                  </a:txBody>
+                  <a:tcPr marT="27432" marB="27432">
+                    <a:solidFill>
+                      <a:srgbClr val="FFFFFF"/>
+                    </a:solidFill>
+                  </a:tcPr>
+                </a:tc>
+              </a:tr>
+              <a:tr h="365760">
+                <a:tc>
+                  <a:txBody>
+                    <a:bodyPr wrap="square"/>
+                    <a:lstStyle/>
+                    <a:p>
+                      <a:r>
+                        <a:rPr sz="1150" b="0">
+                          <a:solidFill>
+                            <a:srgbClr val="202020"/>
+                          </a:solidFill>
+                        </a:rPr>
+                        <a:t>#19</a:t>
+                      </a:r>
+                    </a:p>
+                  </a:txBody>
+                  <a:tcPr marT="27432" marB="27432">
+                    <a:solidFill>
+                      <a:srgbClr val="FFFFFF"/>
+                    </a:solidFill>
+                  </a:tcPr>
+                </a:tc>
+                <a:tc>
+                  <a:txBody>
+                    <a:bodyPr wrap="square"/>
+                    <a:lstStyle/>
+                    <a:p>
+                      <a:r>
+                        <a:rPr sz="1150" b="0">
+                          <a:solidFill>
+                            <a:srgbClr val="202020"/>
+                          </a:solidFill>
+                        </a:rPr>
+                        <a:t>fix</a:t>
+                      </a:r>
+                    </a:p>
+                  </a:txBody>
+                  <a:tcPr marT="27432" marB="27432">
+                    <a:solidFill>
+                      <a:srgbClr val="FFFFFF"/>
+                    </a:solidFill>
+                  </a:tcPr>
+                </a:tc>
+                <a:tc>
+                  <a:txBody>
+                    <a:bodyPr wrap="square"/>
+                    <a:lstStyle/>
+                    <a:p>
+                      <a:r>
+                        <a:rPr sz="1150" b="0">
+                          <a:solidFill>
+                            <a:srgbClr val="202020"/>
+                          </a:solidFill>
+                        </a:rPr>
+                        <a:t>lane 之间判断 token batch 是否有效的竞态</a:t>
+                      </a:r>
+                    </a:p>
+                  </a:txBody>
+                  <a:tcPr marT="27432" marB="27432">
+                    <a:solidFill>
+                      <a:srgbClr val="FFFFFF"/>
+                    </a:solidFill>
+                  </a:tcPr>
+                </a:tc>
+                <a:tc>
+                  <a:txBody>
+                    <a:bodyPr wrap="square"/>
+                    <a:lstStyle/>
+                    <a:p>
+                      <a:r>
+                        <a:rPr sz="1150" b="0">
+                          <a:solidFill>
+                            <a:srgbClr val="202020"/>
+                          </a:solidFill>
+                        </a:rPr>
+                        <a:t>10-13</a:t>
+                      </a:r>
+                    </a:p>
+                  </a:txBody>
+                  <a:tcPr marT="27432" marB="27432">
+                    <a:solidFill>
+                      <a:srgbClr val="FFFFFF"/>
+                    </a:solidFill>
+                  </a:tcPr>
+                </a:tc>
+              </a:tr>
+              <a:tr h="365760">
+                <a:tc>
+                  <a:txBody>
+                    <a:bodyPr wrap="square"/>
+                    <a:lstStyle/>
+                    <a:p>
+                      <a:r>
+                        <a:rPr sz="1150" b="0">
+                          <a:solidFill>
+                            <a:srgbClr val="202020"/>
+                          </a:solidFill>
+                        </a:rPr>
+                        <a:t>#23 #24</a:t>
+                      </a:r>
+                    </a:p>
+                  </a:txBody>
+                  <a:tcPr marT="27432" marB="27432">
+                    <a:solidFill>
+                      <a:srgbClr val="FFFFFF"/>
+                    </a:solidFill>
+                  </a:tcPr>
+                </a:tc>
+                <a:tc>
+                  <a:txBody>
+                    <a:bodyPr wrap="square"/>
+                    <a:lstStyle/>
+                    <a:p>
+                      <a:r>
+                        <a:rPr sz="1150" b="0">
+                          <a:solidFill>
+                            <a:srgbClr val="202020"/>
+                          </a:solidFill>
+                        </a:rPr>
+                        <a:t>fix</a:t>
+                      </a:r>
+                    </a:p>
+                  </a:txBody>
+                  <a:tcPr marT="27432" marB="27432">
+                    <a:solidFill>
+                      <a:srgbClr val="FFFFFF"/>
+                    </a:solidFill>
+                  </a:tcPr>
+                </a:tc>
+                <a:tc>
+                  <a:txBody>
+                    <a:bodyPr wrap="square"/>
+                    <a:lstStyle/>
+                    <a:p>
+                      <a:r>
+                        <a:rPr sz="1150" b="0">
+                          <a:solidFill>
+                            <a:srgbClr val="202020"/>
+                          </a:solidFill>
+                        </a:rPr>
+                        <a:t>proxy warp 退出前 flush；gin.flush 和等 ring 空槽加超时</a:t>
+                      </a:r>
+                    </a:p>
+                  </a:txBody>
+                  <a:tcPr marT="27432" marB="27432">
+                    <a:solidFill>
+                      <a:srgbClr val="FFFFFF"/>
+                    </a:solidFill>
+                  </a:tcPr>
+                </a:tc>
+                <a:tc>
+                  <a:txBody>
+                    <a:bodyPr wrap="square"/>
+                    <a:lstStyle/>
+                    <a:p>
+                      <a:r>
+                        <a:rPr sz="1150" b="0">
+                          <a:solidFill>
+                            <a:srgbClr val="202020"/>
+                          </a:solidFill>
+                        </a:rPr>
+                        <a:t>10-19</a:t>
+                      </a:r>
+                    </a:p>
+                  </a:txBody>
+                  <a:tcPr marT="27432" marB="27432">
+                    <a:solidFill>
+                      <a:srgbClr val="FFFFFF"/>
+                    </a:solidFill>
+                  </a:tcPr>
+                </a:tc>
+              </a:tr>
+              <a:tr h="365760">
+                <a:tc>
+                  <a:txBody>
+                    <a:bodyPr wrap="square"/>
+                    <a:lstStyle/>
+                    <a:p>
+                      <a:r>
+                        <a:rPr sz="1150" b="0">
+                          <a:solidFill>
+                            <a:srgbClr val="202020"/>
+                          </a:solidFill>
+                        </a:rPr>
+                        <a:t>#28</a:t>
+                      </a:r>
+                    </a:p>
+                  </a:txBody>
+                  <a:tcPr marT="27432" marB="27432">
+                    <a:solidFill>
+                      <a:srgbClr val="FFFFFF"/>
+                    </a:solidFill>
+                  </a:tcPr>
+                </a:tc>
+                <a:tc>
+                  <a:txBody>
+                    <a:bodyPr wrap="square"/>
+                    <a:lstStyle/>
+                    <a:p>
+                      <a:r>
+                        <a:rPr sz="1150" b="0">
+                          <a:solidFill>
+                            <a:srgbClr val="202020"/>
+                          </a:solidFill>
+                        </a:rPr>
+                        <a:t>fix</a:t>
+                      </a:r>
+                    </a:p>
+                  </a:txBody>
+                  <a:tcPr marT="27432" marB="27432">
+                    <a:solidFill>
+                      <a:srgbClr val="FFFFFF"/>
+                    </a:solidFill>
+                  </a:tcPr>
+                </a:tc>
+                <a:tc>
+                  <a:txBody>
+                    <a:bodyPr wrap="square"/>
+                    <a:lstStyle/>
+                    <a:p>
+                      <a:r>
+                        <a:rPr sz="1150" b="0">
+                          <a:solidFill>
+                            <a:srgbClr val="202020"/>
+                          </a:solidFill>
+                        </a:rPr>
+                        <a:t>unordered dispatch 退出前 flush GIN（取代 #20）</a:t>
+                      </a:r>
+                    </a:p>
+                  </a:txBody>
+                  <a:tcPr marT="27432" marB="27432">
+                    <a:solidFill>
+                      <a:srgbClr val="FFFFFF"/>
+                    </a:solidFill>
+                  </a:tcPr>
+                </a:tc>
+                <a:tc>
+                  <a:txBody>
+                    <a:bodyPr wrap="square"/>
+                    <a:lstStyle/>
+                    <a:p>
+                      <a:r>
+                        <a:rPr sz="1150" b="0">
+                          <a:solidFill>
+                            <a:srgbClr val="202020"/>
+                          </a:solidFill>
+                        </a:rPr>
+                        <a:t>10-24 · 见下页</a:t>
+                      </a:r>
+                    </a:p>
+                  </a:txBody>
+                  <a:tcPr marT="27432" marB="27432">
+                    <a:solidFill>
+                      <a:srgbClr val="FFFFFF"/>
+                    </a:solidFill>
+                  </a:tcPr>
+                </a:tc>
+              </a:tr>
+              <a:tr h="365760">
+                <a:tc>
+                  <a:txBody>
+                    <a:bodyPr wrap="square"/>
+                    <a:lstStyle/>
+                    <a:p>
+                      <a:r>
+                        <a:rPr sz="1150" b="0">
+                          <a:solidFill>
+                            <a:srgbClr val="202020"/>
+                          </a:solidFill>
+                        </a:rPr>
+                        <a:t>#21</a:t>
+                      </a:r>
+                    </a:p>
+                  </a:txBody>
+                  <a:tcPr marT="27432" marB="27432">
+                    <a:solidFill>
+                      <a:srgbClr val="FFFFFF"/>
+                    </a:solidFill>
+                  </a:tcPr>
+                </a:tc>
+                <a:tc>
+                  <a:txBody>
+                    <a:bodyPr wrap="square"/>
+                    <a:lstStyle/>
+                    <a:p>
+                      <a:r>
+                        <a:rPr sz="1150" b="0">
+                          <a:solidFill>
+                            <a:srgbClr val="202020"/>
+                          </a:solidFill>
+                        </a:rPr>
+                        <a:t>fix</a:t>
+                      </a:r>
+                    </a:p>
+                  </a:txBody>
+                  <a:tcPr marT="27432" marB="27432">
+                    <a:solidFill>
+                      <a:srgbClr val="FFFFFF"/>
+                    </a:solidFill>
+                  </a:tcPr>
+                </a:tc>
+                <a:tc>
+                  <a:txBody>
+                    <a:bodyPr wrap="square"/>
+                    <a:lstStyle/>
+                    <a:p>
+                      <a:r>
+                        <a:rPr sz="1150" b="0">
+                          <a:solidFill>
+                            <a:srgbClr val="202020"/>
+                          </a:solidFill>
+                        </a:rPr>
+                        <a:t>GIN signal 计数器回绕时 shadow 比较失效</a:t>
+                      </a:r>
+                    </a:p>
+                  </a:txBody>
+                  <a:tcPr marT="27432" marB="27432">
+                    <a:solidFill>
+                      <a:srgbClr val="FFFFFF"/>
+                    </a:solidFill>
+                  </a:tcPr>
+                </a:tc>
+                <a:tc>
+                  <a:txBody>
+                    <a:bodyPr wrap="square"/>
+                    <a:lstStyle/>
+                    <a:p>
+                      <a:r>
+                        <a:rPr sz="1150" b="0">
+                          <a:solidFill>
+                            <a:srgbClr val="202020"/>
+                          </a:solidFill>
+                        </a:rPr>
+                        <a:t>10-26</a:t>
+                      </a:r>
+                    </a:p>
+                  </a:txBody>
+                  <a:tcPr marT="27432" marB="27432">
+                    <a:solidFill>
+                      <a:srgbClr val="FFFFFF"/>
+                    </a:solidFill>
+                  </a:tcPr>
+                </a:tc>
+              </a:tr>
+              <a:tr h="365760">
+                <a:tc>
+                  <a:txBody>
+                    <a:bodyPr wrap="square"/>
+                    <a:lstStyle/>
+                    <a:p>
+                      <a:r>
+                        <a:rPr sz="1150" b="0">
+                          <a:solidFill>
+                            <a:srgbClr val="202020"/>
+                          </a:solidFill>
+                        </a:rPr>
+                        <a:t>#32</a:t>
+                      </a:r>
+                    </a:p>
+                  </a:txBody>
+                  <a:tcPr marT="27432" marB="27432">
+                    <a:solidFill>
+                      <a:srgbClr val="FFFFFF"/>
+                    </a:solidFill>
+                  </a:tcPr>
+                </a:tc>
+                <a:tc>
+                  <a:txBody>
+                    <a:bodyPr wrap="square"/>
+                    <a:lstStyle/>
+                    <a:p>
+                      <a:r>
+                        <a:rPr sz="1150" b="0">
+                          <a:solidFill>
+                            <a:srgbClr val="202020"/>
+                          </a:solidFill>
+                        </a:rPr>
+                        <a:t>test</a:t>
+                      </a:r>
+                    </a:p>
+                  </a:txBody>
+                  <a:tcPr marT="27432" marB="27432">
+                    <a:solidFill>
+                      <a:srgbClr val="FFFFFF"/>
+                    </a:solidFill>
+                  </a:tcPr>
+                </a:tc>
+                <a:tc>
+                  <a:txBody>
+                    <a:bodyPr wrap="square"/>
+                    <a:lstStyle/>
+                    <a:p>
+                      <a:r>
+                        <a:rPr sz="1150" b="0">
+                          <a:solidFill>
+                            <a:srgbClr val="202020"/>
+                          </a:solidFill>
+                        </a:rPr>
+                        <a:t>test_ep 按真实 top-k 计算 buffer 大小</a:t>
+                      </a:r>
+                    </a:p>
+                  </a:txBody>
+                  <a:tcPr marT="27432" marB="27432">
+                    <a:solidFill>
+                      <a:srgbClr val="FFFFFF"/>
+                    </a:solidFill>
+                  </a:tcPr>
+                </a:tc>
+                <a:tc>
+                  <a:txBody>
+                    <a:bodyPr wrap="square"/>
+                    <a:lstStyle/>
+                    <a:p>
+                      <a:r>
+                        <a:rPr sz="1150" b="0">
+                          <a:solidFill>
+                            <a:srgbClr val="202020"/>
+                          </a:solidFill>
+                        </a:rPr>
+                        <a:t>10-24</a:t>
+                      </a:r>
+                    </a:p>
+                  </a:txBody>
+                  <a:tcPr marT="27432" marB="27432">
+                    <a:solidFill>
+                      <a:srgbClr val="FFFFFF"/>
+                    </a:solidFill>
+                  </a:tcPr>
+                </a:tc>
+              </a:tr>
+            </a:tbl>
+          </a:graphicData>
+        </a:graphic>
+      </p:graphicFrame>
+      <p:sp>
+        <p:nvSpPr>
+          <p:cNvPr id="6" name="TextBox 5"/>
+          <p:cNvSpPr txBox="1"/>
+          <p:nvPr/>
+        </p:nvSpPr>
+        <p:spPr>
+          <a:xfrm>
+            <a:off x="457200" y="5532120"/>
+            <a:ext cx="11247120" cy="914400"/>
+          </a:xfrm>
+          <a:prstGeom prst="rect">
+            <a:avLst/>
+          </a:prstGeom>
+          <a:noFill/>
+        </p:spPr>
+        <p:txBody>
+          <a:bodyPr wrap="square">
+            <a:spAutoFit/>
+          </a:bodyPr>
+          <a:lstStyle/>
+          <a:p>
+            <a:r>
+              <a:rPr sz="1200" b="0">
+                <a:solidFill>
+                  <a:srgbClr val="202020"/>
+                </a:solidFill>
+              </a:rPr>
+              <a:t>• 未合：#16 combine 优化（b300 prefill combine +12.1%，待查）、#26 proxy 独占 put、#30/#31 dispatch 超时诊断、#33/#34 EP_DEBUG_CHECKS、#35 只在跨 NVLink 域时申请 GIN、#36 迁移到 V2.5</a:t>
+            </a:r>
+          </a:p>
+          <a:p>
+            <a:r>
+              <a:rPr sz="1200" b="0">
+                <a:solidFill>
+                  <a:srgbClr val="202020"/>
+                </a:solidFill>
+              </a:rPr>
+              <a:t>• #1/#2 本身是 CLOSED：#2 的逻辑由 #15 进了 main，所以第 10 页的 EP_NUM_SUB_PARTS 在 main 上不生效</a:t>
+            </a:r>
+          </a:p>
+        </p:txBody>
+      </p:sp>
+    </p:spTree>
+  </p:cSld>
+  <p:clrMapOvr>
+    <a:masterClrMapping/>
+  </p:clrMapOvr>
+</p:sld>
+</file>
+
+<file path=ppt/slides/slide15.xml><?xml version="1.0" encoding="utf-8"?>
+<p:sld xmlns:a="http://schemas.openxmlformats.org/drawingml/2006/main" xmlns:p="http://schemas.openxmlformats.org/presentationml/2006/main" xmlns:r="http://schemas.openxmlformats.org/officeDocument/2006/relationships">
+  <p:cSld>
+    <p:spTree>
+      <p:nvGrpSpPr>
+        <p:cNvPr id="1" name=""/>
+        <p:cNvGrpSpPr/>
+        <p:nvPr/>
+      </p:nvGrpSpPr>
+      <p:grpSpPr/>
+      <p:sp>
+        <p:nvSpPr>
+          <p:cNvPr id="2" name="TextBox 1"/>
+          <p:cNvSpPr txBox="1"/>
+          <p:nvPr/>
+        </p:nvSpPr>
+        <p:spPr>
+          <a:xfrm>
+            <a:off x="365760" y="6492240"/>
+            <a:ext cx="11430000" cy="274320"/>
+          </a:xfrm>
+          <a:prstGeom prst="rect">
+            <a:avLst/>
+          </a:prstGeom>
+          <a:noFill/>
+        </p:spPr>
+        <p:txBody>
+          <a:bodyPr wrap="square">
+            <a:spAutoFit/>
+          </a:bodyPr>
+          <a:lstStyle/>
+          <a:p>
+            <a:r>
+              <a:rPr sz="1000" b="0">
+                <a:solidFill>
+                  <a:srgbClr val="909090"/>
+                </a:solidFill>
+              </a:rPr>
+              <a:t>DeepEP V2 on AWS EFA · 2026-10 · 14/16</a:t>
+            </a:r>
+          </a:p>
+        </p:txBody>
+      </p:sp>
+      <p:sp>
+        <p:nvSpPr>
+          <p:cNvPr id="3" name="TextBox 2"/>
+          <p:cNvSpPr txBox="1"/>
+          <p:nvPr/>
+        </p:nvSpPr>
+        <p:spPr>
+          <a:xfrm>
+            <a:off x="457200" y="320040"/>
+            <a:ext cx="11247120" cy="777240"/>
+          </a:xfrm>
+          <a:prstGeom prst="rect">
+            <a:avLst/>
+          </a:prstGeom>
+          <a:noFill/>
+        </p:spPr>
+        <p:txBody>
+          <a:bodyPr wrap="square">
+            <a:spAutoFit/>
+          </a:bodyPr>
+          <a:lstStyle/>
+          <a:p>
+            <a:r>
+              <a:rPr sz="3000" b="1">
+                <a:solidFill>
+                  <a:srgbClr val="1F4E79"/>
+                </a:solidFill>
+              </a:rPr>
+              <a:t>13 · 两个训练才会遇到的稳定性 bug（都已合入）</a:t>
+            </a:r>
+          </a:p>
+        </p:txBody>
+      </p:sp>
+      <p:sp>
+        <p:nvSpPr>
+          <p:cNvPr id="4" name="TextBox 3"/>
+          <p:cNvSpPr txBox="1"/>
+          <p:nvPr/>
+        </p:nvSpPr>
+        <p:spPr>
+          <a:xfrm>
+            <a:off x="457200" y="1097280"/>
+            <a:ext cx="11247120" cy="411480"/>
+          </a:xfrm>
+          <a:prstGeom prst="rect">
+            <a:avLst/>
+          </a:prstGeom>
+          <a:noFill/>
+        </p:spPr>
+        <p:txBody>
+          <a:bodyPr wrap="square">
+            <a:spAutoFit/>
+          </a:bodyPr>
+          <a:lstStyle/>
+          <a:p>
+            <a:r>
+              <a:rPr sz="1500" b="1">
+                <a:solidFill>
+                  <a:srgbClr val="C0504D"/>
+                </a:solidFill>
+              </a:rPr>
+              <a:t>只在训练里出现：test_ep 压测 60 万次没有触发，Megatron 几分钟就复现</a:t>
+            </a:r>
+          </a:p>
+        </p:txBody>
+      </p:sp>
+      <p:graphicFrame>
+        <p:nvGraphicFramePr>
+          <p:cNvPr id="5" name="Table 4"/>
+          <p:cNvGraphicFramePr>
+            <a:graphicFrameLocks noGrp="1"/>
+          </p:cNvGraphicFramePr>
+          <p:nvPr/>
+        </p:nvGraphicFramePr>
+        <p:xfrm>
+          <a:off x="457200" y="1600200"/>
+          <a:ext cx="11247120" cy="3566160"/>
+        </p:xfrm>
+        <a:graphic>
+          <a:graphicData uri="http://schemas.openxmlformats.org/drawingml/2006/table">
+            <a:tbl>
+              <a:tblPr firstRow="1" bandRow="1">
+                <a:tableStyleId>{5C22544A-7EE6-4342-B048-85BDC9FD1C3A}</a:tableStyleId>
+              </a:tblPr>
+              <a:tblGrid>
+                <a:gridCol w="1188720"/>
+                <a:gridCol w="5029200"/>
+                <a:gridCol w="5029200"/>
+              </a:tblGrid>
+              <a:tr h="713232">
+                <a:tc>
+                  <a:txBody>
+                    <a:bodyPr wrap="square"/>
+                    <a:lstStyle/>
+                    <a:p>
+                      <a:r>
+                        <a:rPr sz="1250" b="1">
+                          <a:solidFill>
+                            <a:srgbClr val="FFFFFF"/>
+                          </a:solidFill>
+                        </a:rPr>
+                        <a:t/>
+                      </a:r>
+                    </a:p>
+                  </a:txBody>
+                  <a:tcPr marT="27432" marB="27432">
+                    <a:solidFill>
+                      <a:srgbClr val="2E75B6"/>
+                    </a:solidFill>
+                  </a:tcPr>
+                </a:tc>
+                <a:tc>
+                  <a:txBody>
+                    <a:bodyPr wrap="square"/>
+                    <a:lstStyle/>
+                    <a:p>
+                      <a:r>
+                        <a:rPr sz="1250" b="1">
+                          <a:solidFill>
+                            <a:srgbClr val="FFFFFF"/>
+                          </a:solidFill>
+                        </a:rPr>
+                        <a:t>#18 cached dispatch 撞 barrier signal</a:t>
+                      </a:r>
+                    </a:p>
+                  </a:txBody>
+                  <a:tcPr marT="27432" marB="27432">
+                    <a:solidFill>
+                      <a:srgbClr val="2E75B6"/>
+                    </a:solidFill>
+                  </a:tcPr>
+                </a:tc>
+                <a:tc>
+                  <a:txBody>
+                    <a:bodyPr wrap="square"/>
+                    <a:lstStyle/>
+                    <a:p>
+                      <a:r>
+                        <a:rPr sz="1250" b="1">
+                          <a:solidFill>
+                            <a:srgbClr val="FFFFFF"/>
+                          </a:solidFill>
+                        </a:rPr>
+                        <a:t>#28（原 #20）kernel 退出时 put 还在飞</a:t>
+                      </a:r>
+                    </a:p>
+                  </a:txBody>
+                  <a:tcPr marT="27432" marB="27432">
+                    <a:solidFill>
+                      <a:srgbClr val="2E75B6"/>
+                    </a:solidFill>
+                  </a:tcPr>
+                </a:tc>
+              </a:tr>
+              <a:tr h="713232">
+                <a:tc>
+                  <a:txBody>
+                    <a:bodyPr wrap="square"/>
+                    <a:lstStyle/>
+                    <a:p>
+                      <a:r>
+                        <a:rPr sz="1150" b="0">
+                          <a:solidFill>
+                            <a:srgbClr val="202020"/>
+                          </a:solidFill>
+                        </a:rPr>
+                        <a:t>现象</a:t>
+                      </a:r>
+                    </a:p>
+                  </a:txBody>
+                  <a:tcPr marT="27432" marB="27432">
+                    <a:solidFill>
+                      <a:srgbClr val="FFFFFF"/>
+                    </a:solidFill>
+                  </a:tcPr>
+                </a:tc>
+                <a:tc>
+                  <a:txBody>
+                    <a:bodyPr wrap="square"/>
+                    <a:lstStyle/>
+                    <a:p>
+                      <a:r>
+                        <a:rPr sz="1150" b="0">
+                          <a:solidFill>
+                            <a:srgbClr val="202020"/>
+                          </a:solidFill>
+                        </a:rPr>
+                        <a:t>Xid 13 → Xid 31（MMU fault，野地址 TMA store）；</a:t>
+                      </a:r>
+                    </a:p>
+                    <a:p>
+                      <a:r>
+                        <a:rPr sz="1150" b="0">
+                          <a:solidFill>
+                            <a:srgbClr val="202020"/>
+                          </a:solidFill>
+                        </a:rPr>
+                        <a:t>约 100 s 后其他 rank 报 barrier timeout；或 grad Inf/NaN</a:t>
+                      </a:r>
+                    </a:p>
+                  </a:txBody>
+                  <a:tcPr marT="27432" marB="27432">
+                    <a:solidFill>
+                      <a:srgbClr val="FFFFFF"/>
+                    </a:solidFill>
+                  </a:tcPr>
+                </a:tc>
+                <a:tc>
+                  <a:txBody>
+                    <a:bodyPr wrap="square"/>
+                    <a:lstStyle/>
+                    <a:p>
+                      <a:r>
+                        <a:rPr sz="1150" b="0">
+                          <a:solidFill>
+                            <a:srgbClr val="202020"/>
+                          </a:solidFill>
+                        </a:rPr>
+                        <a:t>一个 EP 组的所有 rank 同时 grad norm NaN/Inf；</a:t>
+                      </a:r>
+                    </a:p>
+                    <a:p>
+                      <a:r>
+                        <a:rPr sz="1150" b="0">
+                          <a:solidFill>
+                            <a:srgbClr val="202020"/>
+                          </a:solidFill>
+                        </a:rPr>
+                        <a:t>有时先是单个 rank 的 forward loss NaN</a:t>
+                      </a:r>
+                    </a:p>
+                  </a:txBody>
+                  <a:tcPr marT="27432" marB="27432">
+                    <a:solidFill>
+                      <a:srgbClr val="FFFFFF"/>
+                    </a:solidFill>
+                  </a:tcPr>
+                </a:tc>
+              </a:tr>
+              <a:tr h="713232">
+                <a:tc>
+                  <a:txBody>
+                    <a:bodyPr wrap="square"/>
+                    <a:lstStyle/>
+                    <a:p>
+                      <a:r>
+                        <a:rPr sz="1150" b="0">
+                          <a:solidFill>
+                            <a:srgbClr val="202020"/>
+                          </a:solidFill>
+                        </a:rPr>
+                        <a:t>根因</a:t>
+                      </a:r>
+                    </a:p>
+                  </a:txBody>
+                  <a:tcPr marT="27432" marB="27432">
+                    <a:solidFill>
+                      <a:srgbClr val="FFFFFF"/>
+                    </a:solidFill>
+                  </a:tcPr>
+                </a:tc>
+                <a:tc>
+                  <a:txBody>
+                    <a:bodyPr wrap="square"/>
+                    <a:lstStyle/>
+                    <a:p>
+                      <a:r>
+                        <a:rPr sz="1150" b="0">
+                          <a:solidFill>
+                            <a:srgbClr val="202020"/>
+                          </a:solidFill>
+                        </a:rPr>
+                        <a:t>cached dispatch（combine 的反向）里 channel 0–2 落在 QP 0，</a:t>
+                      </a:r>
+                    </a:p>
+                    <a:p>
+                      <a:r>
+                        <a:rPr sz="1150" b="0">
+                          <a:solidFill>
+                            <a:srgbClr val="202020"/>
+                          </a:solidFill>
+                        </a:rPr>
+                        <a:t>signal id 0–2 和 rail barrier 重叠，barrier 的计数被当成数据</a:t>
+                      </a:r>
+                    </a:p>
+                  </a:txBody>
+                  <a:tcPr marT="27432" marB="27432">
+                    <a:solidFill>
+                      <a:srgbClr val="FFFFFF"/>
+                    </a:solidFill>
+                  </a:tcPr>
+                </a:tc>
+                <a:tc>
+                  <a:txBody>
+                    <a:bodyPr wrap="square"/>
+                    <a:lstStyle/>
+                    <a:p>
+                      <a:r>
+                        <a:rPr sz="1150" b="0">
+                          <a:solidFill>
+                            <a:srgbClr val="202020"/>
+                          </a:solidFill>
+                        </a:rPr>
+                        <a:t>unordered dispatch 不等 put 本地完成就退出；下一个 kernel 改写同一块</a:t>
+                      </a:r>
+                    </a:p>
+                    <a:p>
+                      <a:r>
+                        <a:rPr sz="1150" b="0">
+                          <a:solidFill>
+                            <a:srgbClr val="202020"/>
+                          </a:solidFill>
+                        </a:rPr>
+                        <a:t>send buffer，SRD 重传会重读源内存，对端收到下一个 kernel 的字节</a:t>
+                      </a:r>
+                    </a:p>
+                  </a:txBody>
+                  <a:tcPr marT="27432" marB="27432">
+                    <a:solidFill>
+                      <a:srgbClr val="FFFFFF"/>
+                    </a:solidFill>
+                  </a:tcPr>
+                </a:tc>
+              </a:tr>
+              <a:tr h="713232">
+                <a:tc>
+                  <a:txBody>
+                    <a:bodyPr wrap="square"/>
+                    <a:lstStyle/>
+                    <a:p>
+                      <a:r>
+                        <a:rPr sz="1150" b="0">
+                          <a:solidFill>
+                            <a:srgbClr val="202020"/>
+                          </a:solidFill>
+                        </a:rPr>
+                        <a:t>修复</a:t>
+                      </a:r>
+                    </a:p>
+                  </a:txBody>
+                  <a:tcPr marT="27432" marB="27432">
+                    <a:solidFill>
+                      <a:srgbClr val="FFFFFF"/>
+                    </a:solidFill>
+                  </a:tcPr>
+                </a:tc>
+                <a:tc>
+                  <a:txBody>
+                    <a:bodyPr wrap="square"/>
+                    <a:lstStyle/>
+                    <a:p>
+                      <a:r>
+                        <a:rPr sz="1150" b="0">
+                          <a:solidFill>
+                            <a:srgbClr val="202020"/>
+                          </a:solidFill>
+                        </a:rPr>
+                        <a:t>数据通道从 QP 1 开始（kDataChannelsAboveQP0）</a:t>
+                      </a:r>
+                    </a:p>
+                  </a:txBody>
+                  <a:tcPr marT="27432" marB="27432">
+                    <a:solidFill>
+                      <a:srgbClr val="FFFFFF"/>
+                    </a:solidFill>
+                  </a:tcPr>
+                </a:tc>
+                <a:tc>
+                  <a:txBody>
+                    <a:bodyPr wrap="square"/>
+                    <a:lstStyle/>
+                    <a:p>
+                      <a:r>
+                        <a:rPr sz="1150" b="0">
+                          <a:solidFill>
+                            <a:srgbClr val="202020"/>
+                          </a:solidFill>
+                        </a:rPr>
+                        <a:t>退出前 flush 所有 GIN context</a:t>
+                      </a:r>
+                    </a:p>
+                  </a:txBody>
+                  <a:tcPr marT="27432" marB="27432">
+                    <a:solidFill>
+                      <a:srgbClr val="FFFFFF"/>
+                    </a:solidFill>
+                  </a:tcPr>
+                </a:tc>
+              </a:tr>
+              <a:tr h="713232">
+                <a:tc>
+                  <a:txBody>
+                    <a:bodyPr wrap="square"/>
+                    <a:lstStyle/>
+                    <a:p>
+                      <a:r>
+                        <a:rPr sz="1150" b="0">
+                          <a:solidFill>
+                            <a:srgbClr val="202020"/>
+                          </a:solidFill>
+                        </a:rPr>
+                        <a:t>验证</a:t>
+                      </a:r>
+                    </a:p>
+                  </a:txBody>
+                  <a:tcPr marT="27432" marB="27432">
+                    <a:solidFill>
+                      <a:srgbClr val="FFFFFF"/>
+                    </a:solidFill>
+                  </a:tcPr>
+                </a:tc>
+                <a:tc>
+                  <a:txBody>
+                    <a:bodyPr wrap="square"/>
+                    <a:lstStyle/>
+                    <a:p>
+                      <a:r>
+                        <a:rPr sz="1150" b="0">
+                          <a:solidFill>
+                            <a:srgbClr val="202020"/>
+                          </a:solidFill>
+                        </a:rPr>
+                        <a:t>4 × p6-b200，Megatron EP32 A/B：未修复 6/6 次出事（58 min）；</a:t>
+                      </a:r>
+                    </a:p>
+                    <a:p>
+                      <a:r>
+                        <a:rPr sz="1150" b="0">
+                          <a:solidFill>
+                            <a:srgbClr val="202020"/>
+                          </a:solidFill>
+                        </a:rPr>
+                        <a:t>修复后 166 min 0 次。b90a617 第 255 步出事，6de427b 1432 步无事</a:t>
+                      </a:r>
+                    </a:p>
+                  </a:txBody>
+                  <a:tcPr marT="27432" marB="27432">
+                    <a:solidFill>
+                      <a:srgbClr val="FFFFFF"/>
+                    </a:solidFill>
+                  </a:tcPr>
+                </a:tc>
+                <a:tc>
+                  <a:txBody>
+                    <a:bodyPr wrap="square"/>
+                    <a:lstStyle/>
+                    <a:p>
+                      <a:r>
+                        <a:rPr sz="1150" b="0">
+                          <a:solidFill>
+                            <a:srgbClr val="202020"/>
+                          </a:solidFill>
+                        </a:rPr>
+                        <a:t>PR 作者在 FP8 形状下验证（combine 的 scale-up 区压在</a:t>
+                      </a:r>
+                    </a:p>
+                    <a:p>
+                      <a:r>
+                        <a:rPr sz="1150" b="0">
+                          <a:solidFill>
+                            <a:srgbClr val="202020"/>
+                          </a:solidFill>
+                        </a:rPr>
+                        <a:t>dispatch 的 send 区上）；我们没有独立复测</a:t>
+                      </a:r>
+                    </a:p>
+                  </a:txBody>
+                  <a:tcPr marT="27432" marB="27432">
+                    <a:solidFill>
+                      <a:srgbClr val="FFFFFF"/>
+                    </a:solidFill>
+                  </a:tcPr>
+                </a:tc>
+              </a:tr>
+            </a:tbl>
+          </a:graphicData>
+        </a:graphic>
+      </p:graphicFrame>
+      <p:sp>
+        <p:nvSpPr>
+          <p:cNvPr id="6" name="TextBox 5"/>
+          <p:cNvSpPr txBox="1"/>
+          <p:nvPr/>
+        </p:nvSpPr>
+        <p:spPr>
+          <a:xfrm>
+            <a:off x="457200" y="5623560"/>
+            <a:ext cx="11247120" cy="731520"/>
+          </a:xfrm>
+          <a:prstGeom prst="rect">
+            <a:avLst/>
+          </a:prstGeom>
+          <a:noFill/>
+        </p:spPr>
+        <p:txBody>
+          <a:bodyPr wrap="square">
+            <a:spAutoFit/>
+          </a:bodyPr>
+          <a:lstStyle/>
+          <a:p>
+            <a:r>
+              <a:rPr sz="1400" b="1">
+                <a:solidFill>
+                  <a:srgbClr val="202020"/>
+                </a:solidFill>
+              </a:rPr>
+              <a:t>训练用户：直接用当前 main（51815ea），两者都在里面。推理基本不走 cached dispatch，受 #18 影响小。</a:t>
+            </a:r>
+          </a:p>
+        </p:txBody>
+      </p:sp>
+    </p:spTree>
+  </p:cSld>
+  <p:clrMapOvr>
+    <a:masterClrMapping/>
+  </p:clrMapOvr>
+</p:sld>
+</file>
+
+<file path=ppt/slides/slide16.xml><?xml version="1.0" encoding="utf-8"?>
+<p:sld xmlns:a="http://schemas.openxmlformats.org/drawingml/2006/main" xmlns:p="http://schemas.openxmlformats.org/presentationml/2006/main" xmlns:r="http://schemas.openxmlformats.org/officeDocument/2006/relationships">
+  <p:cSld>
+    <p:spTree>
+      <p:nvGrpSpPr>
+        <p:cNvPr id="1" name=""/>
+        <p:cNvGrpSpPr/>
+        <p:nvPr/>
+      </p:nvGrpSpPr>
+      <p:grpSpPr/>
+      <p:sp>
+        <p:nvSpPr>
+          <p:cNvPr id="2" name="TextBox 1"/>
+          <p:cNvSpPr txBox="1"/>
+          <p:nvPr/>
+        </p:nvSpPr>
+        <p:spPr>
+          <a:xfrm>
+            <a:off x="365760" y="6492240"/>
+            <a:ext cx="11430000" cy="274320"/>
+          </a:xfrm>
+          <a:prstGeom prst="rect">
+            <a:avLst/>
+          </a:prstGeom>
+          <a:noFill/>
+        </p:spPr>
+        <p:txBody>
+          <a:bodyPr wrap="square">
+            <a:spAutoFit/>
+          </a:bodyPr>
+          <a:lstStyle/>
+          <a:p>
+            <a:r>
+              <a:rPr sz="1000" b="0">
+                <a:solidFill>
+                  <a:srgbClr val="909090"/>
+                </a:solidFill>
+              </a:rPr>
+              <a:t>DeepEP V2 on AWS EFA · 2026-10 · 15/16</a:t>
+            </a:r>
+          </a:p>
+        </p:txBody>
+      </p:sp>
+      <p:sp>
+        <p:nvSpPr>
+          <p:cNvPr id="3" name="TextBox 2"/>
+          <p:cNvSpPr txBox="1"/>
+          <p:nvPr/>
+        </p:nvSpPr>
+        <p:spPr>
+          <a:xfrm>
+            <a:off x="457200" y="320040"/>
+            <a:ext cx="11247120" cy="777240"/>
+          </a:xfrm>
+          <a:prstGeom prst="rect">
+            <a:avLst/>
+          </a:prstGeom>
+          <a:noFill/>
+        </p:spPr>
+        <p:txBody>
+          <a:bodyPr wrap="square">
+            <a:spAutoFit/>
+          </a:bodyPr>
+          <a:lstStyle/>
+          <a:p>
+            <a:r>
+              <a:rPr sz="3000" b="1">
+                <a:solidFill>
+                  <a:srgbClr val="1F4E79"/>
+                </a:solidFill>
+              </a:rPr>
+              <a:t>14 · DeepEP V2.5 on EFA</a:t>
+            </a:r>
+          </a:p>
+        </p:txBody>
+      </p:sp>
+      <p:sp>
+        <p:nvSpPr>
+          <p:cNvPr id="4" name="TextBox 3"/>
+          <p:cNvSpPr txBox="1"/>
+          <p:nvPr/>
+        </p:nvSpPr>
+        <p:spPr>
+          <a:xfrm>
+            <a:off x="457200" y="1097280"/>
+            <a:ext cx="11247120" cy="411480"/>
+          </a:xfrm>
+          <a:prstGeom prst="rect">
+            <a:avLst/>
+          </a:prstGeom>
+          <a:noFill/>
+        </p:spPr>
+        <p:txBody>
+          <a:bodyPr wrap="square">
+            <a:spAutoFit/>
+          </a:bodyPr>
+          <a:lstStyle/>
+          <a:p>
+            <a:r>
+              <a:rPr sz="1500" b="1">
+                <a:solidFill>
+                  <a:srgbClr val="C0504D"/>
+                </a:solidFill>
+              </a:rPr>
+              <a:t>deepseek-ai/DeepEP main（V2.5）原样在 EFA 上跑不起来；移植后与 V2 main 持平</a:t>
+            </a:r>
+          </a:p>
+        </p:txBody>
+      </p:sp>
+      <p:sp>
+        <p:nvSpPr>
+          <p:cNvPr id="5" name="TextBox 4"/>
+          <p:cNvSpPr txBox="1"/>
+          <p:nvPr/>
+        </p:nvSpPr>
+        <p:spPr>
+          <a:xfrm>
+            <a:off x="457200" y="1554480"/>
+            <a:ext cx="11247120" cy="1828800"/>
+          </a:xfrm>
+          <a:prstGeom prst="rect">
+            <a:avLst/>
+          </a:prstGeom>
+          <a:noFill/>
+        </p:spPr>
+        <p:txBody>
+          <a:bodyPr wrap="square">
+            <a:spAutoFit/>
+          </a:bodyPr>
+          <a:lstStyle/>
+          <a:p>
+            <a:r>
+              <a:rPr sz="1250" b="0">
+                <a:solidFill>
+                  <a:srgbClr val="202020"/>
+                </a:solidFill>
+              </a:rPr>
+              <a:t>• NCCL ≥ 2.32.3 是硬性要求，而 2.32 的 EFA-GDA 要 backendVersion 2：aws-ofi-nccl 1.21.1（installer 1.50.0）只支持 0..1，目前只有 master（452f302 之后）能用</a:t>
+            </a:r>
+          </a:p>
+          <a:p>
+            <a:r>
+              <a:rPr sz="1250" b="0">
+                <a:solidFill>
+                  <a:srgbClr val="202020"/>
+                </a:solidFill>
+              </a:rPr>
+              <a:t>• JIT 只编 GDAKI 一个设备端后端（NCCL_GIN_EFA_GDA_ENABLE=0）→ 第一次 dispatch 就 Xid 13/31，要打开 EFA-GDA</a:t>
+            </a:r>
+          </a:p>
+          <a:p>
+            <a:r>
+              <a:rPr sz="1250" b="0">
+                <a:solidFill>
+                  <a:srgbClr val="202020"/>
+                </a:solidFill>
+              </a:rPr>
+              <a:t>• context.cpp 写死 GDAKI；Engram 强制 NCCL_GIN_TYPE=3，而且 NCCL 默认要求 EFA-GDA 没有的 strong / VA signal</a:t>
+            </a:r>
+          </a:p>
+          <a:p>
+            <a:r>
+              <a:rPr sz="1250" b="0">
+                <a:solidFill>
+                  <a:srgbClr val="202020"/>
+                </a:solidFill>
+              </a:rPr>
+              <a:t>• 还要 NCCL_CUMEM_HOST_ENABLE=0（2.32.3 下 test_ep 里 torch 的 all_to_all 报 host 内存 OOM）和 libdw-dev（DeepJIT）</a:t>
+            </a:r>
+          </a:p>
+        </p:txBody>
+      </p:sp>
+      <p:graphicFrame>
+        <p:nvGraphicFramePr>
+          <p:cNvPr id="6" name="Table 5"/>
+          <p:cNvGraphicFramePr>
+            <a:graphicFrameLocks noGrp="1"/>
+          </p:cNvGraphicFramePr>
+          <p:nvPr/>
+        </p:nvGraphicFramePr>
+        <p:xfrm>
+          <a:off x="457200" y="3337560"/>
+          <a:ext cx="10241280" cy="1828800"/>
+        </p:xfrm>
+        <a:graphic>
+          <a:graphicData uri="http://schemas.openxmlformats.org/drawingml/2006/table">
+            <a:tbl>
+              <a:tblPr firstRow="1" bandRow="1">
+                <a:tableStyleId>{5C22544A-7EE6-4342-B048-85BDC9FD1C3A}</a:tableStyleId>
+              </a:tblPr>
+              <a:tblGrid>
+                <a:gridCol w="2743200"/>
+                <a:gridCol w="1417320"/>
+                <a:gridCol w="1417320"/>
+                <a:gridCol w="914400"/>
+                <a:gridCol w="1417320"/>
+                <a:gridCol w="1417320"/>
+                <a:gridCol w="914400"/>
+              </a:tblGrid>
+              <a:tr h="365760">
+                <a:tc>
+                  <a:txBody>
+                    <a:bodyPr wrap="square"/>
+                    <a:lstStyle/>
+                    <a:p>
+                      <a:r>
+                        <a:rPr sz="1200" b="1">
+                          <a:solidFill>
+                            <a:srgbClr val="FFFFFF"/>
+                          </a:solidFill>
+                        </a:rPr>
+                        <a:t>4 × p6-b200，µs</a:t>
+                      </a:r>
+                    </a:p>
+                  </a:txBody>
+                  <a:tcPr marT="27432" marB="27432">
+                    <a:solidFill>
+                      <a:srgbClr val="2E75B6"/>
+                    </a:solidFill>
+                  </a:tcPr>
+                </a:tc>
+                <a:tc>
+                  <a:txBody>
+                    <a:bodyPr wrap="square"/>
+                    <a:lstStyle/>
+                    <a:p>
+                      <a:r>
+                        <a:rPr sz="1200" b="1">
+                          <a:solidFill>
+                            <a:srgbClr val="FFFFFF"/>
+                          </a:solidFill>
+                        </a:rPr>
+                        <a:t>dispatch</a:t>
+                      </a:r>
+                    </a:p>
+                    <a:p>
+                      <a:r>
+                        <a:rPr sz="1200" b="1">
+                          <a:solidFill>
+                            <a:srgbClr val="FFFFFF"/>
+                          </a:solidFill>
+                        </a:rPr>
+                        <a:t>V2 main</a:t>
+                      </a:r>
+                    </a:p>
+                  </a:txBody>
+                  <a:tcPr marT="27432" marB="27432">
+                    <a:solidFill>
+                      <a:srgbClr val="2E75B6"/>
+                    </a:solidFill>
+                  </a:tcPr>
+                </a:tc>
+                <a:tc>
+                  <a:txBody>
+                    <a:bodyPr wrap="square"/>
+                    <a:lstStyle/>
+                    <a:p>
+                      <a:r>
+                        <a:rPr sz="1200" b="1">
+                          <a:solidFill>
+                            <a:srgbClr val="FFFFFF"/>
+                          </a:solidFill>
+                        </a:rPr>
+                        <a:t>dispatch</a:t>
+                      </a:r>
+                    </a:p>
+                    <a:p>
+                      <a:r>
+                        <a:rPr sz="1200" b="1">
+                          <a:solidFill>
+                            <a:srgbClr val="FFFFFF"/>
+                          </a:solidFill>
+                        </a:rPr>
+                        <a:t>V2.5</a:t>
+                      </a:r>
+                    </a:p>
+                  </a:txBody>
+                  <a:tcPr marT="27432" marB="27432">
+                    <a:solidFill>
+                      <a:srgbClr val="2E75B6"/>
+                    </a:solidFill>
+                  </a:tcPr>
+                </a:tc>
+                <a:tc>
+                  <a:txBody>
+                    <a:bodyPr wrap="square"/>
+                    <a:lstStyle/>
+                    <a:p>
+                      <a:r>
+                        <a:rPr sz="1200" b="1">
+                          <a:solidFill>
+                            <a:srgbClr val="FFFFFF"/>
+                          </a:solidFill>
+                        </a:rPr>
+                        <a:t>Δ</a:t>
+                      </a:r>
+                    </a:p>
+                  </a:txBody>
+                  <a:tcPr marT="27432" marB="27432">
+                    <a:solidFill>
+                      <a:srgbClr val="2E75B6"/>
+                    </a:solidFill>
+                  </a:tcPr>
+                </a:tc>
+                <a:tc>
+                  <a:txBody>
+                    <a:bodyPr wrap="square"/>
+                    <a:lstStyle/>
+                    <a:p>
+                      <a:r>
+                        <a:rPr sz="1200" b="1">
+                          <a:solidFill>
+                            <a:srgbClr val="FFFFFF"/>
+                          </a:solidFill>
+                        </a:rPr>
+                        <a:t>combine</a:t>
+                      </a:r>
+                    </a:p>
+                    <a:p>
+                      <a:r>
+                        <a:rPr sz="1200" b="1">
+                          <a:solidFill>
+                            <a:srgbClr val="FFFFFF"/>
+                          </a:solidFill>
+                        </a:rPr>
+                        <a:t>V2 main</a:t>
+                      </a:r>
+                    </a:p>
+                  </a:txBody>
+                  <a:tcPr marT="27432" marB="27432">
+                    <a:solidFill>
+                      <a:srgbClr val="2E75B6"/>
+                    </a:solidFill>
+                  </a:tcPr>
+                </a:tc>
+                <a:tc>
+                  <a:txBody>
+                    <a:bodyPr wrap="square"/>
+                    <a:lstStyle/>
+                    <a:p>
+                      <a:r>
+                        <a:rPr sz="1200" b="1">
+                          <a:solidFill>
+                            <a:srgbClr val="FFFFFF"/>
+                          </a:solidFill>
+                        </a:rPr>
+                        <a:t>combine</a:t>
+                      </a:r>
+                    </a:p>
+                    <a:p>
+                      <a:r>
+                        <a:rPr sz="1200" b="1">
+                          <a:solidFill>
+                            <a:srgbClr val="FFFFFF"/>
+                          </a:solidFill>
+                        </a:rPr>
+                        <a:t>V2.5</a:t>
+                      </a:r>
+                    </a:p>
+                  </a:txBody>
+                  <a:tcPr marT="27432" marB="27432">
+                    <a:solidFill>
+                      <a:srgbClr val="2E75B6"/>
+                    </a:solidFill>
+                  </a:tcPr>
+                </a:tc>
+                <a:tc>
+                  <a:txBody>
+                    <a:bodyPr wrap="square"/>
+                    <a:lstStyle/>
+                    <a:p>
+                      <a:r>
+                        <a:rPr sz="1200" b="1">
+                          <a:solidFill>
+                            <a:srgbClr val="FFFFFF"/>
+                          </a:solidFill>
+                        </a:rPr>
+                        <a:t>Δ</a:t>
+                      </a:r>
+                    </a:p>
+                  </a:txBody>
+                  <a:tcPr marT="27432" marB="27432">
+                    <a:solidFill>
+                      <a:srgbClr val="2E75B6"/>
+                    </a:solidFill>
+                  </a:tcPr>
+                </a:tc>
+              </a:tr>
+              <a:tr h="365760">
+                <a:tc>
+                  <a:txBody>
+                    <a:bodyPr wrap="square"/>
+                    <a:lstStyle/>
+                    <a:p>
+                      <a:r>
+                        <a:rPr sz="1200" b="0">
+                          <a:solidFill>
+                            <a:srgbClr val="202020"/>
+                          </a:solidFill>
+                        </a:rPr>
+                        <a:t>8192 tok · 24 SM · 2N</a:t>
+                      </a:r>
+                    </a:p>
+                  </a:txBody>
+                  <a:tcPr marT="27432" marB="27432">
+                    <a:solidFill>
+                      <a:srgbClr val="FFFFFF"/>
+                    </a:solidFill>
+                  </a:tcPr>
+                </a:tc>
+                <a:tc>
+                  <a:txBody>
+                    <a:bodyPr wrap="square"/>
+                    <a:lstStyle/>
+                    <a:p>
+                      <a:r>
+                        <a:rPr sz="1200" b="0">
+                          <a:solidFill>
+                            <a:srgbClr val="202020"/>
+                          </a:solidFill>
+                        </a:rPr>
+                        <a:t>1506.8</a:t>
+                      </a:r>
+                    </a:p>
+                  </a:txBody>
+                  <a:tcPr marT="27432" marB="27432">
+                    <a:solidFill>
+                      <a:srgbClr val="FFFFFF"/>
+                    </a:solidFill>
+                  </a:tcPr>
+                </a:tc>
+                <a:tc>
+                  <a:txBody>
+                    <a:bodyPr wrap="square"/>
+                    <a:lstStyle/>
+                    <a:p>
+                      <a:r>
+                        <a:rPr sz="1200" b="0">
+                          <a:solidFill>
+                            <a:srgbClr val="202020"/>
+                          </a:solidFill>
+                        </a:rPr>
+                        <a:t>1503.9</a:t>
+                      </a:r>
+                    </a:p>
+                  </a:txBody>
+                  <a:tcPr marT="27432" marB="27432">
+                    <a:solidFill>
+                      <a:srgbClr val="FFFFFF"/>
+                    </a:solidFill>
+                  </a:tcPr>
+                </a:tc>
+                <a:tc>
+                  <a:txBody>
+                    <a:bodyPr wrap="square"/>
+                    <a:lstStyle/>
+                    <a:p>
+                      <a:r>
+                        <a:rPr sz="1200" b="0">
+                          <a:solidFill>
+                            <a:srgbClr val="202020"/>
+                          </a:solidFill>
+                        </a:rPr>
+                        <a:t>-0.2%</a:t>
+                      </a:r>
+                    </a:p>
+                  </a:txBody>
+                  <a:tcPr marT="27432" marB="27432">
+                    <a:solidFill>
+                      <a:srgbClr val="FFFFFF"/>
+                    </a:solidFill>
+                  </a:tcPr>
+                </a:tc>
+                <a:tc>
+                  <a:txBody>
+                    <a:bodyPr wrap="square"/>
+                    <a:lstStyle/>
+                    <a:p>
+                      <a:r>
+                        <a:rPr sz="1200" b="0">
+                          <a:solidFill>
+                            <a:srgbClr val="202020"/>
+                          </a:solidFill>
+                        </a:rPr>
+                        <a:t>2836.7</a:t>
+                      </a:r>
+                    </a:p>
+                  </a:txBody>
+                  <a:tcPr marT="27432" marB="27432">
+                    <a:solidFill>
+                      <a:srgbClr val="FFFFFF"/>
+                    </a:solidFill>
+                  </a:tcPr>
+                </a:tc>
+                <a:tc>
+                  <a:txBody>
+                    <a:bodyPr wrap="square"/>
+                    <a:lstStyle/>
+                    <a:p>
+                      <a:r>
+                        <a:rPr sz="1200" b="0">
+                          <a:solidFill>
+                            <a:srgbClr val="202020"/>
+                          </a:solidFill>
+                        </a:rPr>
+                        <a:t>2831.9</a:t>
+                      </a:r>
+                    </a:p>
+                  </a:txBody>
+                  <a:tcPr marT="27432" marB="27432">
+                    <a:solidFill>
+                      <a:srgbClr val="FFFFFF"/>
+                    </a:solidFill>
+                  </a:tcPr>
+                </a:tc>
+                <a:tc>
+                  <a:txBody>
+                    <a:bodyPr wrap="square"/>
+                    <a:lstStyle/>
+                    <a:p>
+                      <a:r>
+                        <a:rPr sz="1200" b="0">
+                          <a:solidFill>
+                            <a:srgbClr val="202020"/>
+                          </a:solidFill>
+                        </a:rPr>
+                        <a:t>-0.2%</a:t>
+                      </a:r>
+                    </a:p>
+                  </a:txBody>
+                  <a:tcPr marT="27432" marB="27432">
+                    <a:solidFill>
+                      <a:srgbClr val="FFFFFF"/>
+                    </a:solidFill>
+                  </a:tcPr>
+                </a:tc>
+              </a:tr>
+              <a:tr h="365760">
+                <a:tc>
+                  <a:txBody>
+                    <a:bodyPr wrap="square"/>
+                    <a:lstStyle/>
+                    <a:p>
+                      <a:r>
+                        <a:rPr sz="1200" b="0">
+                          <a:solidFill>
+                            <a:srgbClr val="202020"/>
+                          </a:solidFill>
+                        </a:rPr>
+                        <a:t>8192 tok · 24 SM · 4N</a:t>
+                      </a:r>
+                    </a:p>
+                  </a:txBody>
+                  <a:tcPr marT="27432" marB="27432">
+                    <a:solidFill>
+                      <a:srgbClr val="FFFFFF"/>
+                    </a:solidFill>
+                  </a:tcPr>
+                </a:tc>
+                <a:tc>
+                  <a:txBody>
+                    <a:bodyPr wrap="square"/>
+                    <a:lstStyle/>
+                    <a:p>
+                      <a:r>
+                        <a:rPr sz="1200" b="0">
+                          <a:solidFill>
+                            <a:srgbClr val="202020"/>
+                          </a:solidFill>
+                        </a:rPr>
+                        <a:t>3897.8</a:t>
+                      </a:r>
+                    </a:p>
+                  </a:txBody>
+                  <a:tcPr marT="27432" marB="27432">
+                    <a:solidFill>
+                      <a:srgbClr val="FFFFFF"/>
+                    </a:solidFill>
+                  </a:tcPr>
+                </a:tc>
+                <a:tc>
+                  <a:txBody>
+                    <a:bodyPr wrap="square"/>
+                    <a:lstStyle/>
+                    <a:p>
+                      <a:r>
+                        <a:rPr sz="1200" b="0">
+                          <a:solidFill>
+                            <a:srgbClr val="202020"/>
+                          </a:solidFill>
+                        </a:rPr>
+                        <a:t>3896.7</a:t>
+                      </a:r>
+                    </a:p>
+                  </a:txBody>
+                  <a:tcPr marT="27432" marB="27432">
+                    <a:solidFill>
+                      <a:srgbClr val="FFFFFF"/>
+                    </a:solidFill>
+                  </a:tcPr>
+                </a:tc>
+                <a:tc>
+                  <a:txBody>
+                    <a:bodyPr wrap="square"/>
+                    <a:lstStyle/>
+                    <a:p>
+                      <a:r>
+                        <a:rPr sz="1200" b="0">
+                          <a:solidFill>
+                            <a:srgbClr val="202020"/>
+                          </a:solidFill>
+                        </a:rPr>
+                        <a:t>-0.03%</a:t>
+                      </a:r>
+                    </a:p>
+                  </a:txBody>
+                  <a:tcPr marT="27432" marB="27432">
+                    <a:solidFill>
+                      <a:srgbClr val="FFFFFF"/>
+                    </a:solidFill>
+                  </a:tcPr>
+                </a:tc>
+                <a:tc>
+                  <a:txBody>
+                    <a:bodyPr wrap="square"/>
+                    <a:lstStyle/>
+                    <a:p>
+                      <a:r>
+                        <a:rPr sz="1200" b="0">
+                          <a:solidFill>
+                            <a:srgbClr val="202020"/>
+                          </a:solidFill>
+                        </a:rPr>
+                        <a:t>7351.1</a:t>
+                      </a:r>
+                    </a:p>
+                  </a:txBody>
+                  <a:tcPr marT="27432" marB="27432">
+                    <a:solidFill>
+                      <a:srgbClr val="FFFFFF"/>
+                    </a:solidFill>
+                  </a:tcPr>
+                </a:tc>
+                <a:tc>
+                  <a:txBody>
+                    <a:bodyPr wrap="square"/>
+                    <a:lstStyle/>
+                    <a:p>
+                      <a:r>
+                        <a:rPr sz="1200" b="0">
+                          <a:solidFill>
+                            <a:srgbClr val="202020"/>
+                          </a:solidFill>
+                        </a:rPr>
+                        <a:t>7348.5</a:t>
+                      </a:r>
+                    </a:p>
+                  </a:txBody>
+                  <a:tcPr marT="27432" marB="27432">
+                    <a:solidFill>
+                      <a:srgbClr val="FFFFFF"/>
+                    </a:solidFill>
+                  </a:tcPr>
+                </a:tc>
+                <a:tc>
+                  <a:txBody>
+                    <a:bodyPr wrap="square"/>
+                    <a:lstStyle/>
+                    <a:p>
+                      <a:r>
+                        <a:rPr sz="1200" b="0">
+                          <a:solidFill>
+                            <a:srgbClr val="202020"/>
+                          </a:solidFill>
+                        </a:rPr>
+                        <a:t>-0.04%</a:t>
+                      </a:r>
+                    </a:p>
+                  </a:txBody>
+                  <a:tcPr marT="27432" marB="27432">
+                    <a:solidFill>
+                      <a:srgbClr val="FFFFFF"/>
+                    </a:solidFill>
+                  </a:tcPr>
+                </a:tc>
+              </a:tr>
+              <a:tr h="365760">
+                <a:tc>
+                  <a:txBody>
+                    <a:bodyPr wrap="square"/>
+                    <a:lstStyle/>
+                    <a:p>
+                      <a:r>
+                        <a:rPr sz="1200" b="0">
+                          <a:solidFill>
+                            <a:srgbClr val="202020"/>
+                          </a:solidFill>
+                        </a:rPr>
+                        <a:t>128 tok · 12 SM · 2N</a:t>
+                      </a:r>
+                    </a:p>
+                  </a:txBody>
+                  <a:tcPr marT="27432" marB="27432">
+                    <a:solidFill>
+                      <a:srgbClr val="FFFFFF"/>
+                    </a:solidFill>
+                  </a:tcPr>
+                </a:tc>
+                <a:tc>
+                  <a:txBody>
+                    <a:bodyPr wrap="square"/>
+                    <a:lstStyle/>
+                    <a:p>
+                      <a:r>
+                        <a:rPr sz="1200" b="0">
+                          <a:solidFill>
+                            <a:srgbClr val="202020"/>
+                          </a:solidFill>
+                        </a:rPr>
+                        <a:t>128.6</a:t>
+                      </a:r>
+                    </a:p>
+                  </a:txBody>
+                  <a:tcPr marT="27432" marB="27432">
+                    <a:solidFill>
+                      <a:srgbClr val="FFFFFF"/>
+                    </a:solidFill>
+                  </a:tcPr>
+                </a:tc>
+                <a:tc>
+                  <a:txBody>
+                    <a:bodyPr wrap="square"/>
+                    <a:lstStyle/>
+                    <a:p>
+                      <a:r>
+                        <a:rPr sz="1200" b="0">
+                          <a:solidFill>
+                            <a:srgbClr val="202020"/>
+                          </a:solidFill>
+                        </a:rPr>
+                        <a:t>127.6</a:t>
+                      </a:r>
+                    </a:p>
+                  </a:txBody>
+                  <a:tcPr marT="27432" marB="27432">
+                    <a:solidFill>
+                      <a:srgbClr val="FFFFFF"/>
+                    </a:solidFill>
+                  </a:tcPr>
+                </a:tc>
+                <a:tc>
+                  <a:txBody>
+                    <a:bodyPr wrap="square"/>
+                    <a:lstStyle/>
+                    <a:p>
+                      <a:r>
+                        <a:rPr sz="1200" b="0">
+                          <a:solidFill>
+                            <a:srgbClr val="202020"/>
+                          </a:solidFill>
+                        </a:rPr>
+                        <a:t>-0.8%</a:t>
+                      </a:r>
+                    </a:p>
+                  </a:txBody>
+                  <a:tcPr marT="27432" marB="27432">
+                    <a:solidFill>
+                      <a:srgbClr val="FFFFFF"/>
+                    </a:solidFill>
+                  </a:tcPr>
+                </a:tc>
+                <a:tc>
+                  <a:txBody>
+                    <a:bodyPr wrap="square"/>
+                    <a:lstStyle/>
+                    <a:p>
+                      <a:r>
+                        <a:rPr sz="1200" b="0">
+                          <a:solidFill>
+                            <a:srgbClr val="202020"/>
+                          </a:solidFill>
+                        </a:rPr>
+                        <a:t>173.1</a:t>
+                      </a:r>
+                    </a:p>
+                  </a:txBody>
+                  <a:tcPr marT="27432" marB="27432">
+                    <a:solidFill>
+                      <a:srgbClr val="FFFFFF"/>
+                    </a:solidFill>
+                  </a:tcPr>
+                </a:tc>
+                <a:tc>
+                  <a:txBody>
+                    <a:bodyPr wrap="square"/>
+                    <a:lstStyle/>
+                    <a:p>
+                      <a:r>
+                        <a:rPr sz="1200" b="0">
+                          <a:solidFill>
+                            <a:srgbClr val="202020"/>
+                          </a:solidFill>
+                        </a:rPr>
+                        <a:t>171.2</a:t>
+                      </a:r>
+                    </a:p>
+                  </a:txBody>
+                  <a:tcPr marT="27432" marB="27432">
+                    <a:solidFill>
+                      <a:srgbClr val="FFFFFF"/>
+                    </a:solidFill>
+                  </a:tcPr>
+                </a:tc>
+                <a:tc>
+                  <a:txBody>
+                    <a:bodyPr wrap="square"/>
+                    <a:lstStyle/>
+                    <a:p>
+                      <a:r>
+                        <a:rPr sz="1200" b="0">
+                          <a:solidFill>
+                            <a:srgbClr val="202020"/>
+                          </a:solidFill>
+                        </a:rPr>
+                        <a:t>-1.1%</a:t>
+                      </a:r>
+                    </a:p>
+                  </a:txBody>
+                  <a:tcPr marT="27432" marB="27432">
+                    <a:solidFill>
+                      <a:srgbClr val="FFFFFF"/>
+                    </a:solidFill>
+                  </a:tcPr>
+                </a:tc>
+              </a:tr>
+              <a:tr h="365760">
+                <a:tc>
+                  <a:txBody>
+                    <a:bodyPr wrap="square"/>
+                    <a:lstStyle/>
+                    <a:p>
+                      <a:r>
+                        <a:rPr sz="1200" b="0">
+                          <a:solidFill>
+                            <a:srgbClr val="202020"/>
+                          </a:solidFill>
+                        </a:rPr>
+                        <a:t>128 tok · 12 SM · 4N</a:t>
+                      </a:r>
+                    </a:p>
+                  </a:txBody>
+                  <a:tcPr marT="27432" marB="27432">
+                    <a:solidFill>
+                      <a:srgbClr val="FFFFFF"/>
+                    </a:solidFill>
+                  </a:tcPr>
+                </a:tc>
+                <a:tc>
+                  <a:txBody>
+                    <a:bodyPr wrap="square"/>
+                    <a:lstStyle/>
+                    <a:p>
+                      <a:r>
+                        <a:rPr sz="1200" b="0">
+                          <a:solidFill>
+                            <a:srgbClr val="202020"/>
+                          </a:solidFill>
+                        </a:rPr>
+                        <a:t>178.6</a:t>
+                      </a:r>
+                    </a:p>
+                  </a:txBody>
+                  <a:tcPr marT="27432" marB="27432">
+                    <a:solidFill>
+                      <a:srgbClr val="FFFFFF"/>
+                    </a:solidFill>
+                  </a:tcPr>
+                </a:tc>
+                <a:tc>
+                  <a:txBody>
+                    <a:bodyPr wrap="square"/>
+                    <a:lstStyle/>
+                    <a:p>
+                      <a:r>
+                        <a:rPr sz="1200" b="0">
+                          <a:solidFill>
+                            <a:srgbClr val="202020"/>
+                          </a:solidFill>
+                        </a:rPr>
+                        <a:t>181.8</a:t>
+                      </a:r>
+                    </a:p>
+                  </a:txBody>
+                  <a:tcPr marT="27432" marB="27432">
+                    <a:solidFill>
+                      <a:srgbClr val="FFFFFF"/>
+                    </a:solidFill>
+                  </a:tcPr>
+                </a:tc>
+                <a:tc>
+                  <a:txBody>
+                    <a:bodyPr wrap="square"/>
+                    <a:lstStyle/>
+                    <a:p>
+                      <a:r>
+                        <a:rPr sz="1200" b="0">
+                          <a:solidFill>
+                            <a:srgbClr val="202020"/>
+                          </a:solidFill>
+                        </a:rPr>
+                        <a:t>+1.8%</a:t>
+                      </a:r>
+                    </a:p>
+                  </a:txBody>
+                  <a:tcPr marT="27432" marB="27432">
+                    <a:solidFill>
+                      <a:srgbClr val="FFFFFF"/>
+                    </a:solidFill>
+                  </a:tcPr>
+                </a:tc>
+                <a:tc>
+                  <a:txBody>
+                    <a:bodyPr wrap="square"/>
+                    <a:lstStyle/>
+                    <a:p>
+                      <a:r>
+                        <a:rPr sz="1200" b="0">
+                          <a:solidFill>
+                            <a:srgbClr val="202020"/>
+                          </a:solidFill>
+                        </a:rPr>
+                        <a:t>282.9</a:t>
+                      </a:r>
+                    </a:p>
+                  </a:txBody>
+                  <a:tcPr marT="27432" marB="27432">
+                    <a:solidFill>
+                      <a:srgbClr val="FFFFFF"/>
+                    </a:solidFill>
+                  </a:tcPr>
+                </a:tc>
+                <a:tc>
+                  <a:txBody>
+                    <a:bodyPr wrap="square"/>
+                    <a:lstStyle/>
+                    <a:p>
+                      <a:r>
+                        <a:rPr sz="1200" b="0">
+                          <a:solidFill>
+                            <a:srgbClr val="202020"/>
+                          </a:solidFill>
+                        </a:rPr>
+                        <a:t>278.1</a:t>
+                      </a:r>
+                    </a:p>
+                  </a:txBody>
+                  <a:tcPr marT="27432" marB="27432">
+                    <a:solidFill>
+                      <a:srgbClr val="FFFFFF"/>
+                    </a:solidFill>
+                  </a:tcPr>
+                </a:tc>
+                <a:tc>
+                  <a:txBody>
+                    <a:bodyPr wrap="square"/>
+                    <a:lstStyle/>
+                    <a:p>
+                      <a:r>
+                        <a:rPr sz="1200" b="0">
+                          <a:solidFill>
+                            <a:srgbClr val="202020"/>
+                          </a:solidFill>
+                        </a:rPr>
+                        <a:t>-1.7%</a:t>
+                      </a:r>
+                    </a:p>
+                  </a:txBody>
+                  <a:tcPr marT="27432" marB="27432">
+                    <a:solidFill>
+                      <a:srgbClr val="FFFFFF"/>
+                    </a:solidFill>
+                  </a:tcPr>
+                </a:tc>
+              </a:tr>
+            </a:tbl>
+          </a:graphicData>
+        </a:graphic>
+      </p:graphicFrame>
+      <p:sp>
+        <p:nvSpPr>
+          <p:cNvPr id="7" name="TextBox 6"/>
+          <p:cNvSpPr txBox="1"/>
+          <p:nvPr/>
+        </p:nvSpPr>
+        <p:spPr>
+          <a:xfrm>
+            <a:off x="457200" y="5440680"/>
+            <a:ext cx="11247120" cy="1005840"/>
+          </a:xfrm>
+          <a:prstGeom prst="rect">
+            <a:avLst/>
+          </a:prstGeom>
+          <a:noFill/>
+        </p:spPr>
+        <p:txBody>
+          <a:bodyPr wrap="square">
+            <a:spAutoFit/>
+          </a:bodyPr>
+          <a:lstStyle/>
+          <a:p>
+            <a:r>
+              <a:rPr sz="1150" b="0">
+                <a:solidFill>
+                  <a:srgbClr val="202020"/>
+                </a:solidFill>
+              </a:rPr>
+              <a:t>• 同一套环境（NCCL 2.32.3 + aws-ofi-nccl master，GIN type 5），V2 main = 6de427b，全 rank 均值，2–3 次轮转；4N 全配置 + 20 seed 压测通过。比 V2 时用 --defer-epilogue=0，否则 reduce 看起来慢 50%</a:t>
+            </a:r>
+          </a:p>
+          <a:p>
+            <a:r>
+              <a:rPr sz="1150" b="0">
+                <a:solidFill>
+                  <a:srgbClr val="202020"/>
+                </a:solidFill>
+              </a:rPr>
+              <a:t>• 两条移植：whn09/DeepEP@amazon-v2.5（我们，带性能对比）；amazon-contributing/DeepEP#36（官方，8 节点 p6-b200 / p5en 全矩阵正确性 PASS，待合；已评论 bucket / Engram 的 GIN 布局问题）</a:t>
             </a:r>
           </a:p>
         </p:txBody>
@@ -6491,7 +9143,7 @@
                   <a:srgbClr val="909090"/>
                 </a:solidFill>
               </a:rPr>
-              <a:t>DeepEP V2 on AWS EFA · 2026-08 · 2/13</a:t>
+              <a:t>DeepEP V2 on AWS EFA · 2026-10 · 2/16</a:t>
             </a:r>
           </a:p>
         </p:txBody>
@@ -6766,7 +9418,7 @@
                   <a:srgbClr val="909090"/>
                 </a:solidFill>
               </a:rPr>
-              <a:t>DeepEP V2 on AWS EFA · 2026-08 · 3/13</a:t>
+              <a:t>DeepEP V2 on AWS EFA · 2026-10 · 3/16</a:t>
             </a:r>
           </a:p>
         </p:txBody>
@@ -7435,7 +10087,7 @@
                   <a:srgbClr val="909090"/>
                 </a:solidFill>
               </a:rPr>
-              <a:t>DeepEP V2 on AWS EFA · 2026-08 · 4/13</a:t>
+              <a:t>DeepEP V2 on AWS EFA · 2026-10 · 4/16</a:t>
             </a:r>
           </a:p>
         </p:txBody>
@@ -8133,7 +10785,7 @@
                   <a:srgbClr val="909090"/>
                 </a:solidFill>
               </a:rPr>
-              <a:t>DeepEP V2 on AWS EFA · 2026-08 · 5/13</a:t>
+              <a:t>DeepEP V2 on AWS EFA · 2026-10 · 5/16</a:t>
             </a:r>
           </a:p>
         </p:txBody>
@@ -8804,7 +11456,7 @@
                   <a:srgbClr val="909090"/>
                 </a:solidFill>
               </a:rPr>
-              <a:t>DeepEP V2 on AWS EFA · 2026-08 · 6/13</a:t>
+              <a:t>DeepEP V2 on AWS EFA · 2026-10 · 6/16</a:t>
             </a:r>
           </a:p>
         </p:txBody>
@@ -9099,7 +11751,7 @@
                   <a:srgbClr val="909090"/>
                 </a:solidFill>
               </a:rPr>
-              <a:t>DeepEP V2 on AWS EFA · 2026-08 · 7/13</a:t>
+              <a:t>DeepEP V2 on AWS EFA · 2026-10 · 7/16</a:t>
             </a:r>
           </a:p>
         </p:txBody>
@@ -9342,7 +11994,7 @@
                   <a:srgbClr val="202020"/>
                 </a:solidFill>
               </a:rPr>
-              <a:t>• build DeepEP，pin 到 9c1f2511；sm90-bfbdd15 是 PR #1 + #2 那条臂</a:t>
+              <a:t>• build DeepEP：默认取 main，先解析成 sha 再写进 tag（如 sm100-6de427b），BUILD_REF 记录实际代码</a:t>
             </a:r>
           </a:p>
         </p:txBody>
@@ -9394,7 +12046,7 @@
                   <a:srgbClr val="909090"/>
                 </a:solidFill>
               </a:rPr>
-              <a:t>DeepEP V2 on AWS EFA · 2026-08 · 8/13</a:t>
+              <a:t>DeepEP V2 on AWS EFA · 2026-10 · 8/16</a:t>
             </a:r>
           </a:p>
         </p:txBody>
@@ -9699,7 +12351,7 @@
                   <a:srgbClr val="909090"/>
                 </a:solidFill>
               </a:rPr>
-              <a:t>DeepEP V2 on AWS EFA · 2026-08 · 9/13</a:t>
+              <a:t>DeepEP V2 on AWS EFA · 2026-10 · 9/16</a:t>
             </a:r>
           </a:p>
         </p:txBody>

</xml_diff>